<commit_message>
Update curriculum materials and resource links
</commit_message>
<xml_diff>
--- a/slides/week-01-foundations-knn-v4.pptx
+++ b/slides/week-01-foundations-knn-v4.pptx
@@ -5,7 +5,7 @@
     <p:sldMasterId id="2147483648" r:id="rId1"/>
   </p:sldMasterIdLst>
   <p:notesMasterIdLst>
-    <p:notesMasterId r:id="rId17"/>
+    <p:notesMasterId r:id="rId18"/>
   </p:notesMasterIdLst>
   <p:sldIdLst>
     <p:sldId id="256" r:id="rId2"/>
@@ -23,6 +23,7 @@
     <p:sldId id="268" r:id="rId14"/>
     <p:sldId id="269" r:id="rId15"/>
     <p:sldId id="270" r:id="rId16"/>
+    <p:sldId id="271" r:id="rId17"/>
   </p:sldIdLst>
   <p:sldSz cx="12192000" cy="6858000"/>
   <p:notesSz cx="6858000" cy="9144000"/>
@@ -1275,6 +1276,117 @@
 </p:notes>
 </file>
 
+<file path=ppt/notesSlides/notesSlide16.xml><?xml version="1.0" encoding="utf-8"?>
+<p:notes xmlns:a="http://schemas.openxmlformats.org/drawingml/2006/main" xmlns:r="http://schemas.openxmlformats.org/officeDocument/2006/relationships" xmlns:p="http://schemas.openxmlformats.org/presentationml/2006/main">
+  <p:cSld>
+    <p:spTree>
+      <p:nvGrpSpPr>
+        <p:cNvPr id="1" name="">
+          <a:extLst>
+            <a:ext uri="{FF2B5EF4-FFF2-40B4-BE49-F238E27FC236}">
+              <a16:creationId xmlns:a16="http://schemas.microsoft.com/office/drawing/2014/main" id="{CC65BC85-F684-C51F-50DF-990DF4FE3E8F}"/>
+            </a:ext>
+          </a:extLst>
+        </p:cNvPr>
+        <p:cNvGrpSpPr/>
+        <p:nvPr/>
+      </p:nvGrpSpPr>
+      <p:grpSpPr>
+        <a:xfrm>
+          <a:off x="0" y="0"/>
+          <a:ext cx="0" cy="0"/>
+          <a:chOff x="0" y="0"/>
+          <a:chExt cx="0" cy="0"/>
+        </a:xfrm>
+      </p:grpSpPr>
+      <p:sp>
+        <p:nvSpPr>
+          <p:cNvPr id="2" name="Slide Image Placeholder 1">
+            <a:extLst>
+              <a:ext uri="{FF2B5EF4-FFF2-40B4-BE49-F238E27FC236}">
+                <a16:creationId xmlns:a16="http://schemas.microsoft.com/office/drawing/2014/main" id="{837DF3D0-517C-7331-C6A8-339C6027D882}"/>
+              </a:ext>
+            </a:extLst>
+          </p:cNvPr>
+          <p:cNvSpPr>
+            <a:spLocks noGrp="1" noRot="1" noChangeAspect="1"/>
+          </p:cNvSpPr>
+          <p:nvPr>
+            <p:ph type="sldImg"/>
+          </p:nvPr>
+        </p:nvSpPr>
+        <p:spPr/>
+      </p:sp>
+      <p:sp>
+        <p:nvSpPr>
+          <p:cNvPr id="3" name="Notes Placeholder 2">
+            <a:extLst>
+              <a:ext uri="{FF2B5EF4-FFF2-40B4-BE49-F238E27FC236}">
+                <a16:creationId xmlns:a16="http://schemas.microsoft.com/office/drawing/2014/main" id="{41A015A6-60C9-B3AB-3EC8-E1DC15C1F5FC}"/>
+              </a:ext>
+            </a:extLst>
+          </p:cNvPr>
+          <p:cNvSpPr>
+            <a:spLocks noGrp="1"/>
+          </p:cNvSpPr>
+          <p:nvPr>
+            <p:ph type="body" idx="1"/>
+          </p:nvPr>
+        </p:nvSpPr>
+        <p:spPr/>
+        <p:txBody>
+          <a:bodyPr/>
+          <a:lstStyle/>
+          <a:p>
+            <a:r>
+              <a:t>Collect the checkpoint before students leave. Remind absent students that the notebook includes the same validation cell.</a:t>
+            </a:r>
+          </a:p>
+          <a:p>
+            <a:r>
+              <a:t>Sources: /Users/me/Documents/repos/ai-ml/src/assessments/checkpoints.md; /Users/me/Documents/repos/ai-ml/notebooks/week-01-array-explorer.ipynb</a:t>
+            </a:r>
+          </a:p>
+        </p:txBody>
+      </p:sp>
+      <p:sp>
+        <p:nvSpPr>
+          <p:cNvPr id="4" name="Slide Number Placeholder 3">
+            <a:extLst>
+              <a:ext uri="{FF2B5EF4-FFF2-40B4-BE49-F238E27FC236}">
+                <a16:creationId xmlns:a16="http://schemas.microsoft.com/office/drawing/2014/main" id="{5C8ED007-6796-1A7F-CAED-27CF3420208C}"/>
+              </a:ext>
+            </a:extLst>
+          </p:cNvPr>
+          <p:cNvSpPr>
+            <a:spLocks noGrp="1"/>
+          </p:cNvSpPr>
+          <p:nvPr>
+            <p:ph type="sldNum" idx="5"/>
+          </p:nvPr>
+        </p:nvSpPr>
+        <p:spPr/>
+        <p:txBody>
+          <a:bodyPr/>
+          <a:lstStyle/>
+          <a:p>
+            <a:endParaRPr/>
+          </a:p>
+        </p:txBody>
+      </p:sp>
+    </p:spTree>
+    <p:extLst>
+      <p:ext uri="{BB962C8B-B14F-4D97-AF65-F5344CB8AC3E}">
+        <p14:creationId xmlns:p14="http://schemas.microsoft.com/office/powerpoint/2010/main" val="302167150"/>
+      </p:ext>
+    </p:extLst>
+  </p:cSld>
+  <p:clrMapOvr>
+    <a:masterClrMapping/>
+  </p:clrMapOvr>
+</p:notes>
+</file>
+
 <file path=ppt/notesSlides/notesSlide2.xml><?xml version="1.0" encoding="utf-8"?>
 <p:notes xmlns:a="http://schemas.openxmlformats.org/drawingml/2006/main" xmlns:r="http://schemas.openxmlformats.org/officeDocument/2006/relationships" xmlns:p="http://schemas.openxmlformats.org/presentationml/2006/main">
   <p:cSld>
@@ -2484,7 +2596,7 @@
               </a:defRPr>
             </a:pPr>
             <a:r>
-              <a:rPr sz="2100" b="0">
+              <a:rPr sz="2100" b="0" dirty="0">
                 <a:solidFill>
                   <a:srgbClr val="CFDCE5"/>
                 </a:solidFill>
@@ -2537,7 +2649,13 @@
       </p:sp>
       <p:pic>
         <p:nvPicPr>
-          <p:cNvPr id="12" name="Graphic 11"/>
+          <p:cNvPr id="8" name="Picture 7" descr="A blue and black logo&#10;&#10;AI-generated content may be incorrect.">
+            <a:extLst>
+              <a:ext uri="{FF2B5EF4-FFF2-40B4-BE49-F238E27FC236}">
+                <a16:creationId xmlns:a16="http://schemas.microsoft.com/office/drawing/2014/main" id="{B5E1FA21-7E51-F773-E596-2858909E9549}"/>
+              </a:ext>
+            </a:extLst>
+          </p:cNvPr>
           <p:cNvPicPr>
             <a:picLocks noChangeAspect="1"/>
           </p:cNvPicPr>
@@ -2546,17 +2664,19 @@
         <p:blipFill>
           <a:blip r:embed="rId3">
             <a:extLst>
-              <a:ext uri="{96DAC541-7B7A-43D3-8B79-37D633B846F1}">
-                <asvg:svgBlip xmlns:asvg="http://schemas.microsoft.com/office/drawing/2016/SVG/main" r:embed="rId4"/>
+              <a:ext uri="{28A0092B-C50C-407E-A947-70E740481C1C}">
+                <a14:useLocalDpi xmlns:a14="http://schemas.microsoft.com/office/drawing/2010/main" val="0"/>
               </a:ext>
             </a:extLst>
           </a:blip>
-          <a:stretch/>
+          <a:stretch>
+            <a:fillRect/>
+          </a:stretch>
         </p:blipFill>
         <p:spPr>
           <a:xfrm>
-            <a:off x="9525000" y="5257800"/>
-            <a:ext cx="1809750" cy="781050"/>
+            <a:off x="857250" y="4969713"/>
+            <a:ext cx="3014090" cy="1000772"/>
           </a:xfrm>
           <a:prstGeom prst="rect">
             <a:avLst/>
@@ -6253,7 +6373,7 @@
               </a:defRPr>
             </a:pPr>
             <a:r>
-              <a:rPr sz="1875">
+              <a:rPr sz="1875" dirty="0">
                 <a:solidFill>
                   <a:srgbClr val="475B6A"/>
                 </a:solidFill>
@@ -6280,7 +6400,7 @@
               </a:defRPr>
             </a:pPr>
             <a:r>
-              <a:rPr sz="1875">
+              <a:rPr sz="1875" dirty="0">
                 <a:solidFill>
                   <a:srgbClr val="475B6A"/>
                 </a:solidFill>
@@ -6307,7 +6427,7 @@
               </a:defRPr>
             </a:pPr>
             <a:r>
-              <a:rPr sz="1875">
+              <a:rPr sz="1875" dirty="0">
                 <a:solidFill>
                   <a:srgbClr val="475B6A"/>
                 </a:solidFill>
@@ -6495,6 +6615,332 @@
     <p:extLst>
       <p:ext uri="{BB962C8B-B14F-4D97-AF65-F5344CB8AC3E}">
         <p14:creationId xmlns:p14="http://schemas.microsoft.com/office/powerpoint/2010/main" val="1374926773"/>
+      </p:ext>
+    </p:extLst>
+  </p:cSld>
+  <p:clrMapOvr>
+    <a:masterClrMapping/>
+  </p:clrMapOvr>
+</p:sld>
+</file>
+
+<file path=ppt/slides/slide16.xml><?xml version="1.0" encoding="utf-8"?>
+<p:sld xmlns:a="http://schemas.openxmlformats.org/drawingml/2006/main" xmlns:r="http://schemas.openxmlformats.org/officeDocument/2006/relationships" xmlns:p="http://schemas.openxmlformats.org/presentationml/2006/main">
+  <p:cSld>
+    <p:spTree>
+      <p:nvGrpSpPr>
+        <p:cNvPr id="1" name="">
+          <a:extLst>
+            <a:ext uri="{FF2B5EF4-FFF2-40B4-BE49-F238E27FC236}">
+              <a16:creationId xmlns:a16="http://schemas.microsoft.com/office/drawing/2014/main" id="{7816E81B-7B9B-9471-5309-5EAD201D8EEA}"/>
+            </a:ext>
+          </a:extLst>
+        </p:cNvPr>
+        <p:cNvGrpSpPr/>
+        <p:nvPr/>
+      </p:nvGrpSpPr>
+      <p:grpSpPr>
+        <a:xfrm>
+          <a:off x="0" y="0"/>
+          <a:ext cx="0" cy="0"/>
+          <a:chOff x="0" y="0"/>
+          <a:chExt cx="0" cy="0"/>
+        </a:xfrm>
+      </p:grpSpPr>
+      <p:sp>
+        <p:nvSpPr>
+          <p:cNvPr id="11" name="Rectangle 10">
+            <a:extLst>
+              <a:ext uri="{FF2B5EF4-FFF2-40B4-BE49-F238E27FC236}">
+                <a16:creationId xmlns:a16="http://schemas.microsoft.com/office/drawing/2014/main" id="{A56BDF20-F1BA-F393-EE1B-2F509954F685}"/>
+              </a:ext>
+            </a:extLst>
+          </p:cNvPr>
+          <p:cNvSpPr>
+            <a:spLocks noGrp="1"/>
+          </p:cNvSpPr>
+          <p:nvPr/>
+        </p:nvSpPr>
+        <p:spPr>
+          <a:xfrm>
+            <a:off x="0" y="0"/>
+            <a:ext cx="171450" cy="6858000"/>
+          </a:xfrm>
+          <a:prstGeom prst="rect">
+            <a:avLst/>
+          </a:prstGeom>
+          <a:solidFill>
+            <a:srgbClr val="147D88"/>
+          </a:solidFill>
+          <a:ln w="0">
+            <a:noFill/>
+          </a:ln>
+        </p:spPr>
+        <p:txBody>
+          <a:bodyPr/>
+          <a:lstStyle/>
+          <a:p>
+            <a:endParaRPr lang="en-US"/>
+          </a:p>
+        </p:txBody>
+      </p:sp>
+      <p:sp>
+        <p:nvSpPr>
+          <p:cNvPr id="2" name="Rectangle 1">
+            <a:extLst>
+              <a:ext uri="{FF2B5EF4-FFF2-40B4-BE49-F238E27FC236}">
+                <a16:creationId xmlns:a16="http://schemas.microsoft.com/office/drawing/2014/main" id="{75321DBF-0637-2C0C-6E9F-D8F25B380937}"/>
+              </a:ext>
+            </a:extLst>
+          </p:cNvPr>
+          <p:cNvSpPr>
+            <a:spLocks noGrp="1"/>
+          </p:cNvSpPr>
+          <p:nvPr/>
+        </p:nvSpPr>
+        <p:spPr>
+          <a:xfrm>
+            <a:off x="685800" y="361950"/>
+            <a:ext cx="1714500" cy="266700"/>
+          </a:xfrm>
+          <a:prstGeom prst="rect">
+            <a:avLst/>
+          </a:prstGeom>
+          <a:noFill/>
+          <a:ln w="0">
+            <a:noFill/>
+          </a:ln>
+        </p:spPr>
+        <p:txBody>
+          <a:bodyPr wrap="square" lIns="0" tIns="0" rIns="0" bIns="0" anchor="t">
+            <a:noAutofit/>
+          </a:bodyPr>
+          <a:lstStyle/>
+          <a:p>
+            <a:pPr algn="l">
+              <a:defRPr sz="1425" b="1">
+                <a:solidFill>
+                  <a:srgbClr val="147D88"/>
+                </a:solidFill>
+                <a:latin typeface="Helvetica Neue"/>
+                <a:ea typeface="Helvetica Neue"/>
+                <a:cs typeface="Helvetica Neue"/>
+              </a:defRPr>
+            </a:pPr>
+            <a:r>
+              <a:rPr sz="1425" b="1">
+                <a:solidFill>
+                  <a:srgbClr val="147D88"/>
+                </a:solidFill>
+                <a:latin typeface="Helvetica Neue"/>
+                <a:ea typeface="Helvetica Neue"/>
+                <a:cs typeface="Helvetica Neue"/>
+              </a:rPr>
+              <a:t>WEEK 1</a:t>
+            </a:r>
+          </a:p>
+        </p:txBody>
+      </p:sp>
+      <p:sp>
+        <p:nvSpPr>
+          <p:cNvPr id="3" name="Rectangle 2">
+            <a:extLst>
+              <a:ext uri="{FF2B5EF4-FFF2-40B4-BE49-F238E27FC236}">
+                <a16:creationId xmlns:a16="http://schemas.microsoft.com/office/drawing/2014/main" id="{D1554B3F-10F2-D9CC-F9B8-84695BDFC7E9}"/>
+              </a:ext>
+            </a:extLst>
+          </p:cNvPr>
+          <p:cNvSpPr>
+            <a:spLocks noGrp="1"/>
+          </p:cNvSpPr>
+          <p:nvPr/>
+        </p:nvSpPr>
+        <p:spPr>
+          <a:xfrm>
+            <a:off x="685800" y="723900"/>
+            <a:ext cx="10477500" cy="590550"/>
+          </a:xfrm>
+          <a:prstGeom prst="rect">
+            <a:avLst/>
+          </a:prstGeom>
+          <a:noFill/>
+          <a:ln w="0">
+            <a:noFill/>
+          </a:ln>
+        </p:spPr>
+        <p:txBody>
+          <a:bodyPr wrap="square" lIns="0" tIns="0" rIns="0" bIns="0" anchor="t">
+            <a:noAutofit/>
+          </a:bodyPr>
+          <a:lstStyle/>
+          <a:p>
+            <a:pPr algn="l">
+              <a:defRPr sz="3150" b="1">
+                <a:solidFill>
+                  <a:srgbClr val="132A3A"/>
+                </a:solidFill>
+                <a:latin typeface="Helvetica Neue"/>
+                <a:ea typeface="Helvetica Neue"/>
+                <a:cs typeface="Helvetica Neue"/>
+              </a:defRPr>
+            </a:pPr>
+            <a:r>
+              <a:rPr lang="en-US" sz="3150" b="1" dirty="0">
+                <a:solidFill>
+                  <a:srgbClr val="132A3A"/>
+                </a:solidFill>
+                <a:latin typeface="Helvetica Neue"/>
+                <a:ea typeface="Helvetica Neue"/>
+                <a:cs typeface="Helvetica Neue"/>
+              </a:rPr>
+              <a:t>Attendance!</a:t>
+            </a:r>
+            <a:endParaRPr sz="3150" b="1" dirty="0">
+              <a:solidFill>
+                <a:srgbClr val="132A3A"/>
+              </a:solidFill>
+              <a:latin typeface="Helvetica Neue"/>
+              <a:ea typeface="Helvetica Neue"/>
+              <a:cs typeface="Helvetica Neue"/>
+            </a:endParaRPr>
+          </a:p>
+        </p:txBody>
+      </p:sp>
+      <p:sp>
+        <p:nvSpPr>
+          <p:cNvPr id="4" name="Straight Connector 3">
+            <a:extLst>
+              <a:ext uri="{FF2B5EF4-FFF2-40B4-BE49-F238E27FC236}">
+                <a16:creationId xmlns:a16="http://schemas.microsoft.com/office/drawing/2014/main" id="{969C0BFA-FEA4-F7BA-C4A3-19B4561C879D}"/>
+              </a:ext>
+            </a:extLst>
+          </p:cNvPr>
+          <p:cNvSpPr>
+            <a:spLocks noGrp="1"/>
+          </p:cNvSpPr>
+          <p:nvPr/>
+        </p:nvSpPr>
+        <p:spPr>
+          <a:xfrm>
+            <a:off x="685800" y="1428750"/>
+            <a:ext cx="10744200" cy="0"/>
+          </a:xfrm>
+          <a:prstGeom prst="line">
+            <a:avLst/>
+          </a:prstGeom>
+          <a:noFill/>
+          <a:ln w="19050">
+            <a:solidFill>
+              <a:srgbClr val="CAD4DE"/>
+            </a:solidFill>
+            <a:prstDash val="solid"/>
+          </a:ln>
+        </p:spPr>
+        <p:txBody>
+          <a:bodyPr/>
+          <a:lstStyle/>
+          <a:p>
+            <a:endParaRPr lang="en-US"/>
+          </a:p>
+        </p:txBody>
+      </p:sp>
+      <p:sp>
+        <p:nvSpPr>
+          <p:cNvPr id="5" name="Rectangle 4">
+            <a:extLst>
+              <a:ext uri="{FF2B5EF4-FFF2-40B4-BE49-F238E27FC236}">
+                <a16:creationId xmlns:a16="http://schemas.microsoft.com/office/drawing/2014/main" id="{11A49465-9571-0E4E-680B-86E2F3ABBC8D}"/>
+              </a:ext>
+            </a:extLst>
+          </p:cNvPr>
+          <p:cNvSpPr>
+            <a:spLocks noGrp="1"/>
+          </p:cNvSpPr>
+          <p:nvPr/>
+        </p:nvSpPr>
+        <p:spPr>
+          <a:xfrm>
+            <a:off x="11049000" y="6400800"/>
+            <a:ext cx="400050" cy="209550"/>
+          </a:xfrm>
+          <a:prstGeom prst="rect">
+            <a:avLst/>
+          </a:prstGeom>
+          <a:noFill/>
+          <a:ln w="0">
+            <a:noFill/>
+          </a:ln>
+        </p:spPr>
+        <p:txBody>
+          <a:bodyPr wrap="square" lIns="0" tIns="0" rIns="0" bIns="0" anchor="t">
+            <a:noAutofit/>
+          </a:bodyPr>
+          <a:lstStyle/>
+          <a:p>
+            <a:pPr algn="r">
+              <a:defRPr sz="1200" b="0">
+                <a:solidFill>
+                  <a:srgbClr val="8A9AA6"/>
+                </a:solidFill>
+                <a:latin typeface="Helvetica Neue"/>
+                <a:ea typeface="Helvetica Neue"/>
+                <a:cs typeface="Helvetica Neue"/>
+              </a:defRPr>
+            </a:pPr>
+            <a:r>
+              <a:rPr sz="1200" b="0">
+                <a:solidFill>
+                  <a:srgbClr val="8A9AA6"/>
+                </a:solidFill>
+                <a:latin typeface="Helvetica Neue"/>
+                <a:ea typeface="Helvetica Neue"/>
+                <a:cs typeface="Helvetica Neue"/>
+              </a:rPr>
+              <a:t>15</a:t>
+            </a:r>
+          </a:p>
+        </p:txBody>
+      </p:sp>
+      <p:pic>
+        <p:nvPicPr>
+          <p:cNvPr id="13" name="Picture 12" descr="A qr code with a dinosaur&#10;&#10;AI-generated content may be incorrect.">
+            <a:extLst>
+              <a:ext uri="{FF2B5EF4-FFF2-40B4-BE49-F238E27FC236}">
+                <a16:creationId xmlns:a16="http://schemas.microsoft.com/office/drawing/2014/main" id="{95383789-3F18-3EA5-0609-D290E141D09C}"/>
+              </a:ext>
+            </a:extLst>
+          </p:cNvPr>
+          <p:cNvPicPr>
+            <a:picLocks noChangeAspect="1"/>
+          </p:cNvPicPr>
+          <p:nvPr/>
+        </p:nvPicPr>
+        <p:blipFill>
+          <a:blip r:embed="rId3">
+            <a:extLst>
+              <a:ext uri="{28A0092B-C50C-407E-A947-70E740481C1C}">
+                <a14:useLocalDpi xmlns:a14="http://schemas.microsoft.com/office/drawing/2010/main" val="0"/>
+              </a:ext>
+            </a:extLst>
+          </a:blip>
+          <a:stretch>
+            <a:fillRect/>
+          </a:stretch>
+        </p:blipFill>
+        <p:spPr>
+          <a:xfrm>
+            <a:off x="4409963" y="1884829"/>
+            <a:ext cx="4249271" cy="4249271"/>
+          </a:xfrm>
+          <a:prstGeom prst="rect">
+            <a:avLst/>
+          </a:prstGeom>
+        </p:spPr>
+      </p:pic>
+    </p:spTree>
+    <p:extLst>
+      <p:ext uri="{BB962C8B-B14F-4D97-AF65-F5344CB8AC3E}">
+        <p14:creationId xmlns:p14="http://schemas.microsoft.com/office/powerpoint/2010/main" val="4119922087"/>
       </p:ext>
     </p:extLst>
   </p:cSld>

</xml_diff>